<commit_message>
Bland svarmulighederne, så facit ikke altid står først
Det rigtige svar stod som A i alle 30 spørgsmål, fordi det var sådan de blev
skrevet ned. byg_quiz.py blander nu de fire muligheder med en fast seed, så alle
formater får præcis samme rækkefølge, og scriptet afviser en skæv fordeling.
Facit ligger nu 6 gange på A, 7 på B, 10 på C og 7 på D.

Alle udgaver er bygget om: den interaktive side, regnearket, PowerPointen,
Word- og tekstudgaven, de 30 billeder og overbliks-PDF'en. Regnearkets
facitkolonne er sammenlignet med kilden bagefter, og siden er afprøvet i browser
igen — koderne afkoder stadig præcis rigtigt.

Co-Authored-By: Claude Opus 5 <noreply@anthropic.com>
Claude-Session: https://claude.ai/code/session_01VgEVctXq3tNeZxt6iAFBPu
</commit_message>
<xml_diff>
--- a/facit/kahoot-statistik-2026-09-11.pptx
+++ b/facit/kahoot-statistik-2026-09-11.pptx
@@ -620,7 +620,7 @@
           <a:p>
             <a:r>
               <a:rPr lang="en-US" dirty="0"/>
-              <a:t>Rigtigt svar: triangle (1) — 6</a:t>
+              <a:t>Rigtigt svar: circle (3) — 6</a:t>
             </a:r>
             <a:endParaRPr lang="en-US" dirty="0"/>
           </a:p>
@@ -708,7 +708,7 @@
           <a:p>
             <a:r>
               <a:rPr lang="en-US" dirty="0"/>
-              <a:t>Rigtigt svar: triangle (1) — Ingenting</a:t>
+              <a:t>Rigtigt svar: rectangle (4) — Ingenting</a:t>
             </a:r>
             <a:endParaRPr lang="en-US" dirty="0"/>
           </a:p>
@@ -796,7 +796,7 @@
           <a:p>
             <a:r>
               <a:rPr lang="en-US" dirty="0"/>
-              <a:t>Rigtigt svar: triangle (1) — 8</a:t>
+              <a:t>Rigtigt svar: diamond (2) — 8</a:t>
             </a:r>
             <a:endParaRPr lang="en-US" dirty="0"/>
           </a:p>
@@ -884,7 +884,7 @@
           <a:p>
             <a:r>
               <a:rPr lang="en-US" dirty="0"/>
-              <a:t>Rigtigt svar: triangle (1) — 135°</a:t>
+              <a:t>Rigtigt svar: circle (3) — 135°</a:t>
             </a:r>
             <a:endParaRPr lang="en-US" dirty="0"/>
           </a:p>
@@ -972,7 +972,7 @@
           <a:p>
             <a:r>
               <a:rPr lang="en-US" dirty="0"/>
-              <a:t>Rigtigt svar: triangle (1) — 72°</a:t>
+              <a:t>Rigtigt svar: rectangle (4) — 72°</a:t>
             </a:r>
             <a:endParaRPr lang="en-US" dirty="0"/>
           </a:p>
@@ -1060,7 +1060,7 @@
           <a:p>
             <a:r>
               <a:rPr lang="en-US" dirty="0"/>
-              <a:t>Rigtigt svar: triangle (1) — 25 %</a:t>
+              <a:t>Rigtigt svar: circle (3) — 25 %</a:t>
             </a:r>
             <a:endParaRPr lang="en-US" dirty="0"/>
           </a:p>
@@ -1148,7 +1148,7 @@
           <a:p>
             <a:r>
               <a:rPr lang="en-US" dirty="0"/>
-              <a:t>Rigtigt svar: triangle (1) — Håndbold</a:t>
+              <a:t>Rigtigt svar: circle (3) — Håndbold</a:t>
             </a:r>
             <a:endParaRPr lang="en-US" dirty="0"/>
           </a:p>
@@ -1236,7 +1236,7 @@
           <a:p>
             <a:r>
               <a:rPr lang="en-US" dirty="0"/>
-              <a:t>Rigtigt svar: triangle (1) — 100 %</a:t>
+              <a:t>Rigtigt svar: circle (3) — 100 %</a:t>
             </a:r>
             <a:endParaRPr lang="en-US" dirty="0"/>
           </a:p>
@@ -1412,7 +1412,7 @@
           <a:p>
             <a:r>
               <a:rPr lang="en-US" dirty="0"/>
-              <a:t>Rigtigt svar: triangle (1) — Omkring 172 cm</a:t>
+              <a:t>Rigtigt svar: circle (3) — Omkring 172 cm</a:t>
             </a:r>
             <a:endParaRPr lang="en-US" dirty="0"/>
           </a:p>
@@ -1500,7 +1500,7 @@
           <a:p>
             <a:r>
               <a:rPr lang="en-US" dirty="0"/>
-              <a:t>Rigtigt svar: triangle (1) — 6</a:t>
+              <a:t>Rigtigt svar: circle (3) — 6</a:t>
             </a:r>
             <a:endParaRPr lang="en-US" dirty="0"/>
           </a:p>
@@ -1588,7 +1588,7 @@
           <a:p>
             <a:r>
               <a:rPr lang="en-US" dirty="0"/>
-              <a:t>Rigtigt svar: triangle (1) — 80 %</a:t>
+              <a:t>Rigtigt svar: diamond (2) — 80 %</a:t>
             </a:r>
             <a:endParaRPr lang="en-US" dirty="0"/>
           </a:p>
@@ -1676,7 +1676,7 @@
           <a:p>
             <a:r>
               <a:rPr lang="en-US" dirty="0"/>
-              <a:t>Rigtigt svar: triangle (1) — 4-6 timer</a:t>
+              <a:t>Rigtigt svar: circle (3) — 4-6 timer</a:t>
             </a:r>
             <a:endParaRPr lang="en-US" dirty="0"/>
           </a:p>
@@ -1764,7 +1764,7 @@
           <a:p>
             <a:r>
               <a:rPr lang="en-US" dirty="0"/>
-              <a:t>Rigtigt svar: triangle (1) — 2 gange</a:t>
+              <a:t>Rigtigt svar: diamond (2) — 2 gange</a:t>
             </a:r>
             <a:endParaRPr lang="en-US" dirty="0"/>
           </a:p>
@@ -1852,7 +1852,7 @@
           <a:p>
             <a:r>
               <a:rPr lang="en-US" dirty="0"/>
-              <a:t>Rigtigt svar: triangle (1) — 6 ud af 36</a:t>
+              <a:t>Rigtigt svar: circle (3) — 6 ud af 36</a:t>
             </a:r>
             <a:endParaRPr lang="en-US" dirty="0"/>
           </a:p>
@@ -2116,7 +2116,7 @@
           <a:p>
             <a:r>
               <a:rPr lang="en-US" dirty="0"/>
-              <a:t>Rigtigt svar: triangle (1) — 6 procentpoint</a:t>
+              <a:t>Rigtigt svar: diamond (2) — 6 procentpoint</a:t>
             </a:r>
             <a:endParaRPr lang="en-US" dirty="0"/>
           </a:p>
@@ -2292,7 +2292,7 @@
           <a:p>
             <a:r>
               <a:rPr lang="en-US" dirty="0"/>
-              <a:t>Rigtigt svar: triangle (1) — 9,5 %</a:t>
+              <a:t>Rigtigt svar: diamond (2) — 9,5 %</a:t>
             </a:r>
             <a:endParaRPr lang="en-US" dirty="0"/>
           </a:p>
@@ -2468,7 +2468,7 @@
           <a:p>
             <a:r>
               <a:rPr lang="en-US" dirty="0"/>
-              <a:t>Rigtigt svar: triangle (1) — 5</a:t>
+              <a:t>Rigtigt svar: rectangle (4) — 5</a:t>
             </a:r>
             <a:endParaRPr lang="en-US" dirty="0"/>
           </a:p>
@@ -2556,7 +2556,7 @@
           <a:p>
             <a:r>
               <a:rPr lang="en-US" dirty="0"/>
-              <a:t>Rigtigt svar: triangle (1) — 4 gange</a:t>
+              <a:t>Rigtigt svar: rectangle (4) — 4 gange</a:t>
             </a:r>
             <a:endParaRPr lang="en-US" dirty="0"/>
           </a:p>
@@ -2644,7 +2644,7 @@
           <a:p>
             <a:r>
               <a:rPr lang="en-US" dirty="0"/>
-              <a:t>Rigtigt svar: triangle (1) — Medianen, 24.000 kr</a:t>
+              <a:t>Rigtigt svar: rectangle (4) — Medianen, 24.000 kr</a:t>
             </a:r>
             <a:endParaRPr lang="en-US" dirty="0"/>
           </a:p>
@@ -2820,7 +2820,7 @@
           <a:p>
             <a:r>
               <a:rPr lang="en-US" dirty="0"/>
-              <a:t>Rigtigt svar: triangle (1) — 7</a:t>
+              <a:t>Rigtigt svar: circle (3) — 7</a:t>
             </a:r>
             <a:endParaRPr lang="en-US" dirty="0"/>
           </a:p>
@@ -2908,7 +2908,7 @@
           <a:p>
             <a:r>
               <a:rPr lang="en-US" dirty="0"/>
-              <a:t>Rigtigt svar: triangle (1) — 5</a:t>
+              <a:t>Rigtigt svar: rectangle (4) — 5</a:t>
             </a:r>
             <a:endParaRPr lang="en-US" dirty="0"/>
           </a:p>
@@ -2996,7 +2996,7 @@
           <a:p>
             <a:r>
               <a:rPr lang="en-US" dirty="0"/>
-              <a:t>Rigtigt svar: triangle (1) — 9</a:t>
+              <a:t>Rigtigt svar: rectangle (4) — 9</a:t>
             </a:r>
             <a:endParaRPr lang="en-US" dirty="0"/>
           </a:p>
@@ -3084,7 +3084,7 @@
           <a:p>
             <a:r>
               <a:rPr lang="en-US" dirty="0"/>
-              <a:t>Rigtigt svar: triangle (1) — Mindste, nedre kvartil, median, øvre kvartil, største</a:t>
+              <a:t>Rigtigt svar: diamond (2) — Mindste, nedre kvartil, median, øvre kvartil, største</a:t>
             </a:r>
             <a:endParaRPr lang="en-US" dirty="0"/>
           </a:p>
@@ -3172,7 +3172,7 @@
           <a:p>
             <a:r>
               <a:rPr lang="en-US" dirty="0"/>
-              <a:t>Rigtigt svar: triangle (1) — 50 %</a:t>
+              <a:t>Rigtigt svar: diamond (2) — 50 %</a:t>
             </a:r>
             <a:endParaRPr lang="en-US" dirty="0"/>
           </a:p>
@@ -3808,7 +3808,7 @@
                 <a:ea typeface="Arial" pitchFamily="34" charset="-122"/>
                 <a:cs typeface="Arial" pitchFamily="34" charset="-120"/>
               </a:rPr>
-              <a:t>6</a:t>
+              <a:t>9</a:t>
             </a:r>
             <a:endParaRPr lang="en-US" sz="1300" dirty="0"/>
           </a:p>
@@ -3934,7 +3934,7 @@
                 <a:ea typeface="Arial" pitchFamily="34" charset="-122"/>
                 <a:cs typeface="Arial" pitchFamily="34" charset="-120"/>
               </a:rPr>
-              <a:t>9</a:t>
+              <a:t>6</a:t>
             </a:r>
             <a:endParaRPr lang="en-US" sz="1300" dirty="0"/>
           </a:p>
@@ -4188,7 +4188,7 @@
                 <a:ea typeface="Arial" pitchFamily="34" charset="-122"/>
                 <a:cs typeface="Arial" pitchFamily="34" charset="-120"/>
               </a:rPr>
-              <a:t>Ingenting</a:t>
+              <a:t>Den stiger lidt</a:t>
             </a:r>
             <a:endParaRPr lang="en-US" sz="1300" dirty="0"/>
           </a:p>
@@ -4251,7 +4251,7 @@
                 <a:ea typeface="Arial" pitchFamily="34" charset="-122"/>
                 <a:cs typeface="Arial" pitchFamily="34" charset="-120"/>
               </a:rPr>
-              <a:t>Den bliver dobbelt så stor</a:t>
+              <a:t>Den falder</a:t>
             </a:r>
             <a:endParaRPr lang="en-US" sz="1300" dirty="0"/>
           </a:p>
@@ -4314,7 +4314,7 @@
                 <a:ea typeface="Arial" pitchFamily="34" charset="-122"/>
                 <a:cs typeface="Arial" pitchFamily="34" charset="-120"/>
               </a:rPr>
-              <a:t>Den stiger lidt</a:t>
+              <a:t>Den bliver dobbelt så stor</a:t>
             </a:r>
             <a:endParaRPr lang="en-US" sz="1300" dirty="0"/>
           </a:p>
@@ -4377,7 +4377,7 @@
                 <a:ea typeface="Arial" pitchFamily="34" charset="-122"/>
                 <a:cs typeface="Arial" pitchFamily="34" charset="-120"/>
               </a:rPr>
-              <a:t>Den falder</a:t>
+              <a:t>Ingenting</a:t>
             </a:r>
             <a:endParaRPr lang="en-US" sz="1300" dirty="0"/>
           </a:p>
@@ -4568,7 +4568,7 @@
                 <a:ea typeface="Arial" pitchFamily="34" charset="-122"/>
                 <a:cs typeface="Arial" pitchFamily="34" charset="-120"/>
               </a:rPr>
-              <a:t>8</a:t>
+              <a:t>40</a:t>
             </a:r>
             <a:endParaRPr lang="en-US" sz="1300" dirty="0"/>
           </a:p>
@@ -4631,7 +4631,7 @@
                 <a:ea typeface="Arial" pitchFamily="34" charset="-122"/>
                 <a:cs typeface="Arial" pitchFamily="34" charset="-120"/>
               </a:rPr>
-              <a:t>6</a:t>
+              <a:t>8</a:t>
             </a:r>
             <a:endParaRPr lang="en-US" sz="1300" dirty="0"/>
           </a:p>
@@ -4757,7 +4757,7 @@
                 <a:ea typeface="Arial" pitchFamily="34" charset="-122"/>
                 <a:cs typeface="Arial" pitchFamily="34" charset="-120"/>
               </a:rPr>
-              <a:t>40</a:t>
+              <a:t>6</a:t>
             </a:r>
             <a:endParaRPr lang="en-US" sz="1300" dirty="0"/>
           </a:p>
@@ -4948,7 +4948,7 @@
                 <a:ea typeface="Arial" pitchFamily="34" charset="-122"/>
                 <a:cs typeface="Arial" pitchFamily="34" charset="-120"/>
               </a:rPr>
-              <a:t>135°</a:t>
+              <a:t>90°</a:t>
             </a:r>
             <a:endParaRPr lang="en-US" sz="1300" dirty="0"/>
           </a:p>
@@ -5011,7 +5011,7 @@
                 <a:ea typeface="Arial" pitchFamily="34" charset="-122"/>
                 <a:cs typeface="Arial" pitchFamily="34" charset="-120"/>
               </a:rPr>
-              <a:t>150°</a:t>
+              <a:t>15°</a:t>
             </a:r>
             <a:endParaRPr lang="en-US" sz="1300" dirty="0"/>
           </a:p>
@@ -5074,7 +5074,7 @@
                 <a:ea typeface="Arial" pitchFamily="34" charset="-122"/>
                 <a:cs typeface="Arial" pitchFamily="34" charset="-120"/>
               </a:rPr>
-              <a:t>90°</a:t>
+              <a:t>135°</a:t>
             </a:r>
             <a:endParaRPr lang="en-US" sz="1300" dirty="0"/>
           </a:p>
@@ -5137,7 +5137,7 @@
                 <a:ea typeface="Arial" pitchFamily="34" charset="-122"/>
                 <a:cs typeface="Arial" pitchFamily="34" charset="-120"/>
               </a:rPr>
-              <a:t>15°</a:t>
+              <a:t>150°</a:t>
             </a:r>
             <a:endParaRPr lang="en-US" sz="1300" dirty="0"/>
           </a:p>
@@ -5328,7 +5328,7 @@
                 <a:ea typeface="Arial" pitchFamily="34" charset="-122"/>
                 <a:cs typeface="Arial" pitchFamily="34" charset="-120"/>
               </a:rPr>
-              <a:t>72°</a:t>
+              <a:t>80°</a:t>
             </a:r>
             <a:endParaRPr lang="en-US" sz="1300" dirty="0"/>
           </a:p>
@@ -5391,7 +5391,7 @@
                 <a:ea typeface="Arial" pitchFamily="34" charset="-122"/>
                 <a:cs typeface="Arial" pitchFamily="34" charset="-120"/>
               </a:rPr>
-              <a:t>80°</a:t>
+              <a:t>45°</a:t>
             </a:r>
             <a:endParaRPr lang="en-US" sz="1300" dirty="0"/>
           </a:p>
@@ -5517,7 +5517,7 @@
                 <a:ea typeface="Arial" pitchFamily="34" charset="-122"/>
                 <a:cs typeface="Arial" pitchFamily="34" charset="-120"/>
               </a:rPr>
-              <a:t>45°</a:t>
+              <a:t>72°</a:t>
             </a:r>
             <a:endParaRPr lang="en-US" sz="1300" dirty="0"/>
           </a:p>
@@ -5708,7 +5708,7 @@
                 <a:ea typeface="Arial" pitchFamily="34" charset="-122"/>
                 <a:cs typeface="Arial" pitchFamily="34" charset="-120"/>
               </a:rPr>
-              <a:t>25 %</a:t>
+              <a:t>40 %</a:t>
             </a:r>
             <a:endParaRPr lang="en-US" sz="1300" dirty="0"/>
           </a:p>
@@ -5834,7 +5834,7 @@
                 <a:ea typeface="Arial" pitchFamily="34" charset="-122"/>
                 <a:cs typeface="Arial" pitchFamily="34" charset="-120"/>
               </a:rPr>
-              <a:t>40 %</a:t>
+              <a:t>25 %</a:t>
             </a:r>
             <a:endParaRPr lang="en-US" sz="1300" dirty="0"/>
           </a:p>
@@ -6088,7 +6088,7 @@
                 <a:ea typeface="Arial" pitchFamily="34" charset="-122"/>
                 <a:cs typeface="Arial" pitchFamily="34" charset="-120"/>
               </a:rPr>
-              <a:t>Håndbold</a:t>
+              <a:t>Svømning</a:t>
             </a:r>
             <a:endParaRPr lang="en-US" sz="1300" dirty="0"/>
           </a:p>
@@ -6151,7 +6151,7 @@
                 <a:ea typeface="Arial" pitchFamily="34" charset="-122"/>
                 <a:cs typeface="Arial" pitchFamily="34" charset="-120"/>
               </a:rPr>
-              <a:t>Fodbold</a:t>
+              <a:t>Andet</a:t>
             </a:r>
             <a:endParaRPr lang="en-US" sz="1300" dirty="0"/>
           </a:p>
@@ -6214,7 +6214,7 @@
                 <a:ea typeface="Arial" pitchFamily="34" charset="-122"/>
                 <a:cs typeface="Arial" pitchFamily="34" charset="-120"/>
               </a:rPr>
-              <a:t>Svømning</a:t>
+              <a:t>Håndbold</a:t>
             </a:r>
             <a:endParaRPr lang="en-US" sz="1300" dirty="0"/>
           </a:p>
@@ -6277,7 +6277,7 @@
                 <a:ea typeface="Arial" pitchFamily="34" charset="-122"/>
                 <a:cs typeface="Arial" pitchFamily="34" charset="-120"/>
               </a:rPr>
-              <a:t>Andet</a:t>
+              <a:t>Fodbold</a:t>
             </a:r>
             <a:endParaRPr lang="en-US" sz="1300" dirty="0"/>
           </a:p>
@@ -6468,7 +6468,7 @@
                 <a:ea typeface="Arial" pitchFamily="34" charset="-122"/>
                 <a:cs typeface="Arial" pitchFamily="34" charset="-120"/>
               </a:rPr>
-              <a:t>100 %</a:t>
+              <a:t>360 %</a:t>
             </a:r>
             <a:endParaRPr lang="en-US" sz="1300" dirty="0"/>
           </a:p>
@@ -6531,7 +6531,7 @@
                 <a:ea typeface="Arial" pitchFamily="34" charset="-122"/>
                 <a:cs typeface="Arial" pitchFamily="34" charset="-120"/>
               </a:rPr>
-              <a:t>360 %</a:t>
+              <a:t>Gennemsnittet</a:t>
             </a:r>
             <a:endParaRPr lang="en-US" sz="1300" dirty="0"/>
           </a:p>
@@ -6594,7 +6594,7 @@
                 <a:ea typeface="Arial" pitchFamily="34" charset="-122"/>
                 <a:cs typeface="Arial" pitchFamily="34" charset="-120"/>
               </a:rPr>
-              <a:t>Antallet af observationer</a:t>
+              <a:t>100 %</a:t>
             </a:r>
             <a:endParaRPr lang="en-US" sz="1300" dirty="0"/>
           </a:p>
@@ -6657,7 +6657,7 @@
                 <a:ea typeface="Arial" pitchFamily="34" charset="-122"/>
                 <a:cs typeface="Arial" pitchFamily="34" charset="-120"/>
               </a:rPr>
-              <a:t>Gennemsnittet</a:t>
+              <a:t>Antallet af observationer</a:t>
             </a:r>
             <a:endParaRPr lang="en-US" sz="1300" dirty="0"/>
           </a:p>
@@ -7228,7 +7228,7 @@
                 <a:ea typeface="Arial" pitchFamily="34" charset="-122"/>
                 <a:cs typeface="Arial" pitchFamily="34" charset="-120"/>
               </a:rPr>
-              <a:t>Omkring 172 cm</a:t>
+              <a:t>Omkring 155 cm</a:t>
             </a:r>
             <a:endParaRPr lang="en-US" sz="1300" dirty="0"/>
           </a:p>
@@ -7354,7 +7354,7 @@
                 <a:ea typeface="Arial" pitchFamily="34" charset="-122"/>
                 <a:cs typeface="Arial" pitchFamily="34" charset="-120"/>
               </a:rPr>
-              <a:t>Omkring 180 cm</a:t>
+              <a:t>Omkring 172 cm</a:t>
             </a:r>
             <a:endParaRPr lang="en-US" sz="1300" dirty="0"/>
           </a:p>
@@ -7417,7 +7417,7 @@
                 <a:ea typeface="Arial" pitchFamily="34" charset="-122"/>
                 <a:cs typeface="Arial" pitchFamily="34" charset="-120"/>
               </a:rPr>
-              <a:t>Omkring 155 cm</a:t>
+              <a:t>Omkring 180 cm</a:t>
             </a:r>
             <a:endParaRPr lang="en-US" sz="1300" dirty="0"/>
           </a:p>
@@ -7608,7 +7608,7 @@
                 <a:ea typeface="Arial" pitchFamily="34" charset="-122"/>
                 <a:cs typeface="Arial" pitchFamily="34" charset="-120"/>
               </a:rPr>
-              <a:t>6</a:t>
+              <a:t>8</a:t>
             </a:r>
             <a:endParaRPr lang="en-US" sz="1300" dirty="0"/>
           </a:p>
@@ -7734,7 +7734,7 @@
                 <a:ea typeface="Arial" pitchFamily="34" charset="-122"/>
                 <a:cs typeface="Arial" pitchFamily="34" charset="-120"/>
               </a:rPr>
-              <a:t>5</a:t>
+              <a:t>6</a:t>
             </a:r>
             <a:endParaRPr lang="en-US" sz="1300" dirty="0"/>
           </a:p>
@@ -7797,7 +7797,7 @@
                 <a:ea typeface="Arial" pitchFamily="34" charset="-122"/>
                 <a:cs typeface="Arial" pitchFamily="34" charset="-120"/>
               </a:rPr>
-              <a:t>8</a:t>
+              <a:t>5</a:t>
             </a:r>
             <a:endParaRPr lang="en-US" sz="1300" dirty="0"/>
           </a:p>
@@ -7988,7 +7988,7 @@
                 <a:ea typeface="Arial" pitchFamily="34" charset="-122"/>
                 <a:cs typeface="Arial" pitchFamily="34" charset="-120"/>
               </a:rPr>
-              <a:t>80 %</a:t>
+              <a:t>25 %</a:t>
             </a:r>
             <a:endParaRPr lang="en-US" sz="1300" dirty="0"/>
           </a:p>
@@ -8051,7 +8051,7 @@
                 <a:ea typeface="Arial" pitchFamily="34" charset="-122"/>
                 <a:cs typeface="Arial" pitchFamily="34" charset="-120"/>
               </a:rPr>
-              <a:t>25 %</a:t>
+              <a:t>80 %</a:t>
             </a:r>
             <a:endParaRPr lang="en-US" sz="1300" dirty="0"/>
           </a:p>
@@ -8114,7 +8114,7 @@
                 <a:ea typeface="Arial" pitchFamily="34" charset="-122"/>
                 <a:cs typeface="Arial" pitchFamily="34" charset="-120"/>
               </a:rPr>
-              <a:t>100 %</a:t>
+              <a:t>35 %</a:t>
             </a:r>
             <a:endParaRPr lang="en-US" sz="1300" dirty="0"/>
           </a:p>
@@ -8177,7 +8177,7 @@
                 <a:ea typeface="Arial" pitchFamily="34" charset="-122"/>
                 <a:cs typeface="Arial" pitchFamily="34" charset="-120"/>
               </a:rPr>
-              <a:t>35 %</a:t>
+              <a:t>100 %</a:t>
             </a:r>
             <a:endParaRPr lang="en-US" sz="1300" dirty="0"/>
           </a:p>
@@ -8368,7 +8368,7 @@
                 <a:ea typeface="Arial" pitchFamily="34" charset="-122"/>
                 <a:cs typeface="Arial" pitchFamily="34" charset="-120"/>
               </a:rPr>
-              <a:t>4-6 timer</a:t>
+              <a:t>2-4 timer</a:t>
             </a:r>
             <a:endParaRPr lang="en-US" sz="1300" dirty="0"/>
           </a:p>
@@ -8494,7 +8494,7 @@
                 <a:ea typeface="Arial" pitchFamily="34" charset="-122"/>
                 <a:cs typeface="Arial" pitchFamily="34" charset="-120"/>
               </a:rPr>
-              <a:t>2-4 timer</a:t>
+              <a:t>4-6 timer</a:t>
             </a:r>
             <a:endParaRPr lang="en-US" sz="1300" dirty="0"/>
           </a:p>
@@ -8748,7 +8748,7 @@
                 <a:ea typeface="Arial" pitchFamily="34" charset="-122"/>
                 <a:cs typeface="Arial" pitchFamily="34" charset="-120"/>
               </a:rPr>
-              <a:t>2 gange</a:t>
+              <a:t>4 gange</a:t>
             </a:r>
             <a:endParaRPr lang="en-US" sz="1300" dirty="0"/>
           </a:p>
@@ -8811,7 +8811,7 @@
                 <a:ea typeface="Arial" pitchFamily="34" charset="-122"/>
                 <a:cs typeface="Arial" pitchFamily="34" charset="-120"/>
               </a:rPr>
-              <a:t>1 gang</a:t>
+              <a:t>2 gange</a:t>
             </a:r>
             <a:endParaRPr lang="en-US" sz="1300" dirty="0"/>
           </a:p>
@@ -8937,7 +8937,7 @@
                 <a:ea typeface="Arial" pitchFamily="34" charset="-122"/>
                 <a:cs typeface="Arial" pitchFamily="34" charset="-120"/>
               </a:rPr>
-              <a:t>4 gange</a:t>
+              <a:t>1 gang</a:t>
             </a:r>
             <a:endParaRPr lang="en-US" sz="1300" dirty="0"/>
           </a:p>
@@ -9128,7 +9128,7 @@
                 <a:ea typeface="Arial" pitchFamily="34" charset="-122"/>
                 <a:cs typeface="Arial" pitchFamily="34" charset="-120"/>
               </a:rPr>
-              <a:t>6 ud af 36</a:t>
+              <a:t>7 ud af 36</a:t>
             </a:r>
             <a:endParaRPr lang="en-US" sz="1300" dirty="0"/>
           </a:p>
@@ -9254,7 +9254,7 @@
                 <a:ea typeface="Arial" pitchFamily="34" charset="-122"/>
                 <a:cs typeface="Arial" pitchFamily="34" charset="-120"/>
               </a:rPr>
-              <a:t>7 ud af 36</a:t>
+              <a:t>6 ud af 36</a:t>
             </a:r>
             <a:endParaRPr lang="en-US" sz="1300" dirty="0"/>
           </a:p>
@@ -10014,7 +10014,7 @@
                 <a:ea typeface="Arial" pitchFamily="34" charset="-122"/>
                 <a:cs typeface="Arial" pitchFamily="34" charset="-120"/>
               </a:rPr>
-              <a:t>12 ud af 36</a:t>
+              <a:t>2 ud af 36</a:t>
             </a:r>
             <a:endParaRPr lang="en-US" sz="1300" dirty="0"/>
           </a:p>
@@ -10077,7 +10077,7 @@
                 <a:ea typeface="Arial" pitchFamily="34" charset="-122"/>
                 <a:cs typeface="Arial" pitchFamily="34" charset="-120"/>
               </a:rPr>
-              <a:t>2 ud af 36</a:t>
+              <a:t>12 ud af 36</a:t>
             </a:r>
             <a:endParaRPr lang="en-US" sz="1300" dirty="0"/>
           </a:p>
@@ -10268,7 +10268,7 @@
                 <a:ea typeface="Arial" pitchFamily="34" charset="-122"/>
                 <a:cs typeface="Arial" pitchFamily="34" charset="-120"/>
               </a:rPr>
-              <a:t>6 procentpoint</a:t>
+              <a:t>21 procentpoint</a:t>
             </a:r>
             <a:endParaRPr lang="en-US" sz="1300" dirty="0"/>
           </a:p>
@@ -10331,7 +10331,7 @@
                 <a:ea typeface="Arial" pitchFamily="34" charset="-122"/>
                 <a:cs typeface="Arial" pitchFamily="34" charset="-120"/>
               </a:rPr>
-              <a:t>40 procentpoint</a:t>
+              <a:t>6 procentpoint</a:t>
             </a:r>
             <a:endParaRPr lang="en-US" sz="1300" dirty="0"/>
           </a:p>
@@ -10457,7 +10457,7 @@
                 <a:ea typeface="Arial" pitchFamily="34" charset="-122"/>
                 <a:cs typeface="Arial" pitchFamily="34" charset="-120"/>
               </a:rPr>
-              <a:t>21 procentpoint</a:t>
+              <a:t>40 procentpoint</a:t>
             </a:r>
             <a:endParaRPr lang="en-US" sz="1300" dirty="0"/>
           </a:p>
@@ -10711,7 +10711,7 @@
                 <a:ea typeface="Arial" pitchFamily="34" charset="-122"/>
                 <a:cs typeface="Arial" pitchFamily="34" charset="-120"/>
               </a:rPr>
-              <a:t>6 %</a:t>
+              <a:t>36 %</a:t>
             </a:r>
             <a:endParaRPr lang="en-US" sz="1300" dirty="0"/>
           </a:p>
@@ -10837,7 +10837,7 @@
                 <a:ea typeface="Arial" pitchFamily="34" charset="-122"/>
                 <a:cs typeface="Arial" pitchFamily="34" charset="-120"/>
               </a:rPr>
-              <a:t>36 %</a:t>
+              <a:t>6 %</a:t>
             </a:r>
             <a:endParaRPr lang="en-US" sz="1300" dirty="0"/>
           </a:p>
@@ -11028,7 +11028,7 @@
                 <a:ea typeface="Arial" pitchFamily="34" charset="-122"/>
                 <a:cs typeface="Arial" pitchFamily="34" charset="-120"/>
               </a:rPr>
-              <a:t>9,5 %</a:t>
+              <a:t>38 %</a:t>
             </a:r>
             <a:endParaRPr lang="en-US" sz="1300" dirty="0"/>
           </a:p>
@@ -11091,7 +11091,7 @@
                 <a:ea typeface="Arial" pitchFamily="34" charset="-122"/>
                 <a:cs typeface="Arial" pitchFamily="34" charset="-120"/>
               </a:rPr>
-              <a:t>38 %</a:t>
+              <a:t>9,5 %</a:t>
             </a:r>
             <a:endParaRPr lang="en-US" sz="1300" dirty="0"/>
           </a:p>
@@ -11154,7 +11154,7 @@
                 <a:ea typeface="Arial" pitchFamily="34" charset="-122"/>
                 <a:cs typeface="Arial" pitchFamily="34" charset="-120"/>
               </a:rPr>
-              <a:t>10,5 %</a:t>
+              <a:t>90,5 %</a:t>
             </a:r>
             <a:endParaRPr lang="en-US" sz="1300" dirty="0"/>
           </a:p>
@@ -11217,7 +11217,7 @@
                 <a:ea typeface="Arial" pitchFamily="34" charset="-122"/>
                 <a:cs typeface="Arial" pitchFamily="34" charset="-120"/>
               </a:rPr>
-              <a:t>90,5 %</a:t>
+              <a:t>10,5 %</a:t>
             </a:r>
             <a:endParaRPr lang="en-US" sz="1300" dirty="0"/>
           </a:p>
@@ -11471,7 +11471,7 @@
                 <a:ea typeface="Arial" pitchFamily="34" charset="-122"/>
                 <a:cs typeface="Arial" pitchFamily="34" charset="-120"/>
               </a:rPr>
-              <a:t>Forskellene ser mindre ud, end de er</a:t>
+              <a:t>Ingenting — tallene er jo de samme</a:t>
             </a:r>
             <a:endParaRPr lang="en-US" sz="1300" dirty="0"/>
           </a:p>
@@ -11534,7 +11534,7 @@
                 <a:ea typeface="Arial" pitchFamily="34" charset="-122"/>
                 <a:cs typeface="Arial" pitchFamily="34" charset="-120"/>
               </a:rPr>
-              <a:t>Ingenting — tallene er jo de samme</a:t>
+              <a:t>Diagrammet bliver ulovligt</a:t>
             </a:r>
             <a:endParaRPr lang="en-US" sz="1300" dirty="0"/>
           </a:p>
@@ -11597,7 +11597,7 @@
                 <a:ea typeface="Arial" pitchFamily="34" charset="-122"/>
                 <a:cs typeface="Arial" pitchFamily="34" charset="-120"/>
               </a:rPr>
-              <a:t>Diagrammet bliver ulovligt</a:t>
+              <a:t>Forskellene ser mindre ud, end de er</a:t>
             </a:r>
             <a:endParaRPr lang="en-US" sz="1300" dirty="0"/>
           </a:p>
@@ -11788,7 +11788,7 @@
                 <a:ea typeface="Arial" pitchFamily="34" charset="-122"/>
                 <a:cs typeface="Arial" pitchFamily="34" charset="-120"/>
               </a:rPr>
-              <a:t>5</a:t>
+              <a:t>6</a:t>
             </a:r>
             <a:endParaRPr lang="en-US" sz="1300" dirty="0"/>
           </a:p>
@@ -11851,7 +11851,7 @@
                 <a:ea typeface="Arial" pitchFamily="34" charset="-122"/>
                 <a:cs typeface="Arial" pitchFamily="34" charset="-120"/>
               </a:rPr>
-              <a:t>6</a:t>
+              <a:t>13</a:t>
             </a:r>
             <a:endParaRPr lang="en-US" sz="1300" dirty="0"/>
           </a:p>
@@ -11977,7 +11977,7 @@
                 <a:ea typeface="Arial" pitchFamily="34" charset="-122"/>
                 <a:cs typeface="Arial" pitchFamily="34" charset="-120"/>
               </a:rPr>
-              <a:t>13</a:t>
+              <a:t>5</a:t>
             </a:r>
             <a:endParaRPr lang="en-US" sz="1300" dirty="0"/>
           </a:p>
@@ -12168,7 +12168,7 @@
                 <a:ea typeface="Arial" pitchFamily="34" charset="-122"/>
                 <a:cs typeface="Arial" pitchFamily="34" charset="-120"/>
               </a:rPr>
-              <a:t>4 gange</a:t>
+              <a:t>8 gange</a:t>
             </a:r>
             <a:endParaRPr lang="en-US" sz="1300" dirty="0"/>
           </a:p>
@@ -12294,7 +12294,7 @@
                 <a:ea typeface="Arial" pitchFamily="34" charset="-122"/>
                 <a:cs typeface="Arial" pitchFamily="34" charset="-120"/>
               </a:rPr>
-              <a:t>8 gange</a:t>
+              <a:t>16 gange</a:t>
             </a:r>
             <a:endParaRPr lang="en-US" sz="1300" dirty="0"/>
           </a:p>
@@ -12357,7 +12357,7 @@
                 <a:ea typeface="Arial" pitchFamily="34" charset="-122"/>
                 <a:cs typeface="Arial" pitchFamily="34" charset="-120"/>
               </a:rPr>
-              <a:t>16 gange</a:t>
+              <a:t>4 gange</a:t>
             </a:r>
             <a:endParaRPr lang="en-US" sz="1300" dirty="0"/>
           </a:p>
@@ -12548,7 +12548,7 @@
                 <a:ea typeface="Arial" pitchFamily="34" charset="-122"/>
                 <a:cs typeface="Arial" pitchFamily="34" charset="-120"/>
               </a:rPr>
-              <a:t>Medianen, 24.000 kr</a:t>
+              <a:t>Gennemsnittet, 98.800 kr</a:t>
             </a:r>
             <a:endParaRPr lang="en-US" sz="1300" dirty="0"/>
           </a:p>
@@ -12611,7 +12611,7 @@
                 <a:ea typeface="Arial" pitchFamily="34" charset="-122"/>
                 <a:cs typeface="Arial" pitchFamily="34" charset="-120"/>
               </a:rPr>
-              <a:t>Gennemsnittet, 98.800 kr</a:t>
+              <a:t>Summen af de fem</a:t>
             </a:r>
             <a:endParaRPr lang="en-US" sz="1300" dirty="0"/>
           </a:p>
@@ -12737,7 +12737,7 @@
                 <a:ea typeface="Arial" pitchFamily="34" charset="-122"/>
                 <a:cs typeface="Arial" pitchFamily="34" charset="-120"/>
               </a:rPr>
-              <a:t>Summen af de fem</a:t>
+              <a:t>Medianen, 24.000 kr</a:t>
             </a:r>
             <a:endParaRPr lang="en-US" sz="1300" dirty="0"/>
           </a:p>
@@ -12991,7 +12991,7 @@
                 <a:ea typeface="Arial" pitchFamily="34" charset="-122"/>
                 <a:cs typeface="Arial" pitchFamily="34" charset="-120"/>
               </a:rPr>
-              <a:t>13</a:t>
+              <a:t>3</a:t>
             </a:r>
             <a:endParaRPr lang="en-US" sz="1300" dirty="0"/>
           </a:p>
@@ -13054,7 +13054,7 @@
                 <a:ea typeface="Arial" pitchFamily="34" charset="-122"/>
                 <a:cs typeface="Arial" pitchFamily="34" charset="-120"/>
               </a:rPr>
-              <a:t>3</a:t>
+              <a:t>13</a:t>
             </a:r>
             <a:endParaRPr lang="en-US" sz="1300" dirty="0"/>
           </a:p>
@@ -13308,7 +13308,7 @@
                 <a:ea typeface="Arial" pitchFamily="34" charset="-122"/>
                 <a:cs typeface="Arial" pitchFamily="34" charset="-120"/>
               </a:rPr>
-              <a:t>7</a:t>
+              <a:t>49</a:t>
             </a:r>
             <a:endParaRPr lang="en-US" sz="1300" dirty="0"/>
           </a:p>
@@ -13434,7 +13434,7 @@
                 <a:ea typeface="Arial" pitchFamily="34" charset="-122"/>
                 <a:cs typeface="Arial" pitchFamily="34" charset="-120"/>
               </a:rPr>
-              <a:t>5</a:t>
+              <a:t>7</a:t>
             </a:r>
             <a:endParaRPr lang="en-US" sz="1300" dirty="0"/>
           </a:p>
@@ -13497,7 +13497,7 @@
                 <a:ea typeface="Arial" pitchFamily="34" charset="-122"/>
                 <a:cs typeface="Arial" pitchFamily="34" charset="-120"/>
               </a:rPr>
-              <a:t>49</a:t>
+              <a:t>5</a:t>
             </a:r>
             <a:endParaRPr lang="en-US" sz="1300" dirty="0"/>
           </a:p>
@@ -13688,7 +13688,7 @@
                 <a:ea typeface="Arial" pitchFamily="34" charset="-122"/>
                 <a:cs typeface="Arial" pitchFamily="34" charset="-120"/>
               </a:rPr>
-              <a:t>5</a:t>
+              <a:t>9</a:t>
             </a:r>
             <a:endParaRPr lang="en-US" sz="1300" dirty="0"/>
           </a:p>
@@ -13751,7 +13751,7 @@
                 <a:ea typeface="Arial" pitchFamily="34" charset="-122"/>
                 <a:cs typeface="Arial" pitchFamily="34" charset="-120"/>
               </a:rPr>
-              <a:t>3</a:t>
+              <a:t>6</a:t>
             </a:r>
             <a:endParaRPr lang="en-US" sz="1300" dirty="0"/>
           </a:p>
@@ -13814,7 +13814,7 @@
                 <a:ea typeface="Arial" pitchFamily="34" charset="-122"/>
                 <a:cs typeface="Arial" pitchFamily="34" charset="-120"/>
               </a:rPr>
-              <a:t>6</a:t>
+              <a:t>3</a:t>
             </a:r>
             <a:endParaRPr lang="en-US" sz="1300" dirty="0"/>
           </a:p>
@@ -13877,7 +13877,7 @@
                 <a:ea typeface="Arial" pitchFamily="34" charset="-122"/>
                 <a:cs typeface="Arial" pitchFamily="34" charset="-120"/>
               </a:rPr>
-              <a:t>9</a:t>
+              <a:t>5</a:t>
             </a:r>
             <a:endParaRPr lang="en-US" sz="1300" dirty="0"/>
           </a:p>
@@ -14068,7 +14068,7 @@
                 <a:ea typeface="Arial" pitchFamily="34" charset="-122"/>
                 <a:cs typeface="Arial" pitchFamily="34" charset="-120"/>
               </a:rPr>
-              <a:t>9</a:t>
+              <a:t>8</a:t>
             </a:r>
             <a:endParaRPr lang="en-US" sz="1300" dirty="0"/>
           </a:p>
@@ -14257,7 +14257,7 @@
                 <a:ea typeface="Arial" pitchFamily="34" charset="-122"/>
                 <a:cs typeface="Arial" pitchFamily="34" charset="-120"/>
               </a:rPr>
-              <a:t>8</a:t>
+              <a:t>9</a:t>
             </a:r>
             <a:endParaRPr lang="en-US" sz="1300" dirty="0"/>
           </a:p>
@@ -14448,7 +14448,7 @@
                 <a:ea typeface="Arial" pitchFamily="34" charset="-122"/>
                 <a:cs typeface="Arial" pitchFamily="34" charset="-120"/>
               </a:rPr>
-              <a:t>Mindste, nedre kvartil, median, øvre kvartil, største</a:t>
+              <a:t>Gennemsnit, median, typetal, sum og antal</a:t>
             </a:r>
             <a:endParaRPr lang="en-US" sz="1300" dirty="0"/>
           </a:p>
@@ -14511,7 +14511,7 @@
                 <a:ea typeface="Arial" pitchFamily="34" charset="-122"/>
                 <a:cs typeface="Arial" pitchFamily="34" charset="-120"/>
               </a:rPr>
-              <a:t>Mindste, gennemsnit, median, typetal, største</a:t>
+              <a:t>Mindste, nedre kvartil, median, øvre kvartil, største</a:t>
             </a:r>
             <a:endParaRPr lang="en-US" sz="1300" dirty="0"/>
           </a:p>
@@ -14574,7 +14574,7 @@
                 <a:ea typeface="Arial" pitchFamily="34" charset="-122"/>
                 <a:cs typeface="Arial" pitchFamily="34" charset="-120"/>
               </a:rPr>
-              <a:t>De fem mindste tal i datasættet</a:t>
+              <a:t>Mindste, gennemsnit, median, typetal, største</a:t>
             </a:r>
             <a:endParaRPr lang="en-US" sz="1300" dirty="0"/>
           </a:p>
@@ -14637,7 +14637,7 @@
                 <a:ea typeface="Arial" pitchFamily="34" charset="-122"/>
                 <a:cs typeface="Arial" pitchFamily="34" charset="-120"/>
               </a:rPr>
-              <a:t>Gennemsnit, median, typetal, sum og antal</a:t>
+              <a:t>De fem mindste tal i datasættet</a:t>
             </a:r>
             <a:endParaRPr lang="en-US" sz="1300" dirty="0"/>
           </a:p>
@@ -14828,7 +14828,7 @@
                 <a:ea typeface="Arial" pitchFamily="34" charset="-122"/>
                 <a:cs typeface="Arial" pitchFamily="34" charset="-120"/>
               </a:rPr>
-              <a:t>50 %</a:t>
+              <a:t>25 %</a:t>
             </a:r>
             <a:endParaRPr lang="en-US" sz="1300" dirty="0"/>
           </a:p>
@@ -14891,7 +14891,7 @@
                 <a:ea typeface="Arial" pitchFamily="34" charset="-122"/>
                 <a:cs typeface="Arial" pitchFamily="34" charset="-120"/>
               </a:rPr>
-              <a:t>25 %</a:t>
+              <a:t>50 %</a:t>
             </a:r>
             <a:endParaRPr lang="en-US" sz="1300" dirty="0"/>
           </a:p>

</xml_diff>